<commit_message>
Updated API usage guide for #52
</commit_message>
<xml_diff>
--- a/docs/CitationReviewerGuide.pptx
+++ b/docs/CitationReviewerGuide.pptx
@@ -121,6 +121,11 @@
       </a:defRPr>
     </a:lvl9pPr>
   </p:defaultTextStyle>
+  <p:extLst>
+    <p:ext uri="{EFAFB233-063F-42B5-8137-9DF3F51BA10A}">
+      <p15:sldGuideLst xmlns:p15="http://schemas.microsoft.com/office/powerpoint/2012/main"/>
+    </p:ext>
+  </p:extLst>
 </p:presentation>
 </file>
 
@@ -271,7 +276,7 @@
           <a:p>
             <a:fld id="{A570D5E4-9820-8A4C-880B-D00DFB29381F}" type="datetimeFigureOut">
               <a:rPr lang="en-GB" smtClean="0"/>
-              <a:t>29/04/2026</a:t>
+              <a:t>30/04/2026</a:t>
             </a:fld>
             <a:endParaRPr lang="en-GB"/>
           </a:p>
@@ -469,7 +474,7 @@
           <a:p>
             <a:fld id="{A570D5E4-9820-8A4C-880B-D00DFB29381F}" type="datetimeFigureOut">
               <a:rPr lang="en-GB" smtClean="0"/>
-              <a:t>29/04/2026</a:t>
+              <a:t>30/04/2026</a:t>
             </a:fld>
             <a:endParaRPr lang="en-GB"/>
           </a:p>
@@ -677,7 +682,7 @@
           <a:p>
             <a:fld id="{A570D5E4-9820-8A4C-880B-D00DFB29381F}" type="datetimeFigureOut">
               <a:rPr lang="en-GB" smtClean="0"/>
-              <a:t>29/04/2026</a:t>
+              <a:t>30/04/2026</a:t>
             </a:fld>
             <a:endParaRPr lang="en-GB"/>
           </a:p>
@@ -875,7 +880,7 @@
           <a:p>
             <a:fld id="{A570D5E4-9820-8A4C-880B-D00DFB29381F}" type="datetimeFigureOut">
               <a:rPr lang="en-GB" smtClean="0"/>
-              <a:t>29/04/2026</a:t>
+              <a:t>30/04/2026</a:t>
             </a:fld>
             <a:endParaRPr lang="en-GB"/>
           </a:p>
@@ -1150,7 +1155,7 @@
           <a:p>
             <a:fld id="{A570D5E4-9820-8A4C-880B-D00DFB29381F}" type="datetimeFigureOut">
               <a:rPr lang="en-GB" smtClean="0"/>
-              <a:t>29/04/2026</a:t>
+              <a:t>30/04/2026</a:t>
             </a:fld>
             <a:endParaRPr lang="en-GB"/>
           </a:p>
@@ -1415,7 +1420,7 @@
           <a:p>
             <a:fld id="{A570D5E4-9820-8A4C-880B-D00DFB29381F}" type="datetimeFigureOut">
               <a:rPr lang="en-GB" smtClean="0"/>
-              <a:t>29/04/2026</a:t>
+              <a:t>30/04/2026</a:t>
             </a:fld>
             <a:endParaRPr lang="en-GB"/>
           </a:p>
@@ -1827,7 +1832,7 @@
           <a:p>
             <a:fld id="{A570D5E4-9820-8A4C-880B-D00DFB29381F}" type="datetimeFigureOut">
               <a:rPr lang="en-GB" smtClean="0"/>
-              <a:t>29/04/2026</a:t>
+              <a:t>30/04/2026</a:t>
             </a:fld>
             <a:endParaRPr lang="en-GB"/>
           </a:p>
@@ -1968,7 +1973,7 @@
           <a:p>
             <a:fld id="{A570D5E4-9820-8A4C-880B-D00DFB29381F}" type="datetimeFigureOut">
               <a:rPr lang="en-GB" smtClean="0"/>
-              <a:t>29/04/2026</a:t>
+              <a:t>30/04/2026</a:t>
             </a:fld>
             <a:endParaRPr lang="en-GB"/>
           </a:p>
@@ -2081,7 +2086,7 @@
           <a:p>
             <a:fld id="{A570D5E4-9820-8A4C-880B-D00DFB29381F}" type="datetimeFigureOut">
               <a:rPr lang="en-GB" smtClean="0"/>
-              <a:t>29/04/2026</a:t>
+              <a:t>30/04/2026</a:t>
             </a:fld>
             <a:endParaRPr lang="en-GB"/>
           </a:p>
@@ -2392,7 +2397,7 @@
           <a:p>
             <a:fld id="{A570D5E4-9820-8A4C-880B-D00DFB29381F}" type="datetimeFigureOut">
               <a:rPr lang="en-GB" smtClean="0"/>
-              <a:t>29/04/2026</a:t>
+              <a:t>30/04/2026</a:t>
             </a:fld>
             <a:endParaRPr lang="en-GB"/>
           </a:p>
@@ -2680,7 +2685,7 @@
           <a:p>
             <a:fld id="{A570D5E4-9820-8A4C-880B-D00DFB29381F}" type="datetimeFigureOut">
               <a:rPr lang="en-GB" smtClean="0"/>
-              <a:t>29/04/2026</a:t>
+              <a:t>30/04/2026</a:t>
             </a:fld>
             <a:endParaRPr lang="en-GB"/>
           </a:p>
@@ -2921,7 +2926,7 @@
           <a:p>
             <a:fld id="{A570D5E4-9820-8A4C-880B-D00DFB29381F}" type="datetimeFigureOut">
               <a:rPr lang="en-GB" smtClean="0"/>
-              <a:t>29/04/2026</a:t>
+              <a:t>30/04/2026</a:t>
             </a:fld>
             <a:endParaRPr lang="en-GB"/>
           </a:p>
@@ -3390,6 +3395,59 @@
             <a:r>
               <a:rPr lang="en-GB" dirty="0"/>
               <a:t>Usage Guide for Reviewers</a:t>
+            </a:r>
+          </a:p>
+        </p:txBody>
+      </p:sp>
+      <p:sp>
+        <p:nvSpPr>
+          <p:cNvPr id="4" name="TextBox 3">
+            <a:extLst>
+              <a:ext uri="{FF2B5EF4-FFF2-40B4-BE49-F238E27FC236}">
+                <a16:creationId xmlns:a16="http://schemas.microsoft.com/office/drawing/2014/main" id="{3B29D905-8505-0E3A-BA52-87C4ECB24C59}"/>
+              </a:ext>
+            </a:extLst>
+          </p:cNvPr>
+          <p:cNvSpPr txBox="1"/>
+          <p:nvPr/>
+        </p:nvSpPr>
+        <p:spPr>
+          <a:xfrm>
+            <a:off x="251460" y="6240780"/>
+            <a:ext cx="11766363" cy="369332"/>
+          </a:xfrm>
+          <a:prstGeom prst="rect">
+            <a:avLst/>
+          </a:prstGeom>
+          <a:noFill/>
+        </p:spPr>
+        <p:txBody>
+          <a:bodyPr wrap="none" rtlCol="0">
+            <a:spAutoFit/>
+          </a:bodyPr>
+          <a:lstStyle/>
+          <a:p>
+            <a:r>
+              <a:rPr lang="en-GB" dirty="0"/>
+              <a:t>Daniel Westwood (</a:t>
+            </a:r>
+            <a:r>
+              <a:rPr lang="en-GB" dirty="0">
+                <a:hlinkClick r:id="rId2"/>
+              </a:rPr>
+              <a:t>daniel.westwood@stfc.ac.uk</a:t>
+            </a:r>
+            <a:r>
+              <a:rPr lang="en-GB" dirty="0"/>
+              <a:t>) 						30</a:t>
+            </a:r>
+            <a:r>
+              <a:rPr lang="en-GB" baseline="30000" dirty="0"/>
+              <a:t>th</a:t>
+            </a:r>
+            <a:r>
+              <a:rPr lang="en-GB" dirty="0"/>
+              <a:t> April 2026</a:t>
             </a:r>
           </a:p>
         </p:txBody>

</xml_diff>

<commit_message>
Added admin docs, updates to UI
</commit_message>
<xml_diff>
--- a/docs/CitationReviewerGuide.pptx
+++ b/docs/CitationReviewerGuide.pptx
@@ -14,15 +14,16 @@
     <p:sldId id="265" r:id="rId8"/>
     <p:sldId id="267" r:id="rId9"/>
     <p:sldId id="268" r:id="rId10"/>
-    <p:sldId id="269" r:id="rId11"/>
-    <p:sldId id="270" r:id="rId12"/>
-    <p:sldId id="271" r:id="rId13"/>
-    <p:sldId id="272" r:id="rId14"/>
-    <p:sldId id="273" r:id="rId15"/>
-    <p:sldId id="263" r:id="rId16"/>
-    <p:sldId id="261" r:id="rId17"/>
-    <p:sldId id="262" r:id="rId18"/>
-    <p:sldId id="274" r:id="rId19"/>
+    <p:sldId id="275" r:id="rId11"/>
+    <p:sldId id="269" r:id="rId12"/>
+    <p:sldId id="270" r:id="rId13"/>
+    <p:sldId id="271" r:id="rId14"/>
+    <p:sldId id="272" r:id="rId15"/>
+    <p:sldId id="273" r:id="rId16"/>
+    <p:sldId id="263" r:id="rId17"/>
+    <p:sldId id="261" r:id="rId18"/>
+    <p:sldId id="262" r:id="rId19"/>
+    <p:sldId id="274" r:id="rId20"/>
   </p:sldIdLst>
   <p:sldSz cx="12192000" cy="6858000"/>
   <p:notesSz cx="6858000" cy="9144000"/>
@@ -276,7 +277,7 @@
           <a:p>
             <a:fld id="{A570D5E4-9820-8A4C-880B-D00DFB29381F}" type="datetimeFigureOut">
               <a:rPr lang="en-GB" smtClean="0"/>
-              <a:t>30/04/2026</a:t>
+              <a:t>17/08/2026</a:t>
             </a:fld>
             <a:endParaRPr lang="en-GB"/>
           </a:p>
@@ -474,7 +475,7 @@
           <a:p>
             <a:fld id="{A570D5E4-9820-8A4C-880B-D00DFB29381F}" type="datetimeFigureOut">
               <a:rPr lang="en-GB" smtClean="0"/>
-              <a:t>30/04/2026</a:t>
+              <a:t>17/08/2026</a:t>
             </a:fld>
             <a:endParaRPr lang="en-GB"/>
           </a:p>
@@ -682,7 +683,7 @@
           <a:p>
             <a:fld id="{A570D5E4-9820-8A4C-880B-D00DFB29381F}" type="datetimeFigureOut">
               <a:rPr lang="en-GB" smtClean="0"/>
-              <a:t>30/04/2026</a:t>
+              <a:t>17/08/2026</a:t>
             </a:fld>
             <a:endParaRPr lang="en-GB"/>
           </a:p>
@@ -880,7 +881,7 @@
           <a:p>
             <a:fld id="{A570D5E4-9820-8A4C-880B-D00DFB29381F}" type="datetimeFigureOut">
               <a:rPr lang="en-GB" smtClean="0"/>
-              <a:t>30/04/2026</a:t>
+              <a:t>17/08/2026</a:t>
             </a:fld>
             <a:endParaRPr lang="en-GB"/>
           </a:p>
@@ -1155,7 +1156,7 @@
           <a:p>
             <a:fld id="{A570D5E4-9820-8A4C-880B-D00DFB29381F}" type="datetimeFigureOut">
               <a:rPr lang="en-GB" smtClean="0"/>
-              <a:t>30/04/2026</a:t>
+              <a:t>17/08/2026</a:t>
             </a:fld>
             <a:endParaRPr lang="en-GB"/>
           </a:p>
@@ -1420,7 +1421,7 @@
           <a:p>
             <a:fld id="{A570D5E4-9820-8A4C-880B-D00DFB29381F}" type="datetimeFigureOut">
               <a:rPr lang="en-GB" smtClean="0"/>
-              <a:t>30/04/2026</a:t>
+              <a:t>17/08/2026</a:t>
             </a:fld>
             <a:endParaRPr lang="en-GB"/>
           </a:p>
@@ -1832,7 +1833,7 @@
           <a:p>
             <a:fld id="{A570D5E4-9820-8A4C-880B-D00DFB29381F}" type="datetimeFigureOut">
               <a:rPr lang="en-GB" smtClean="0"/>
-              <a:t>30/04/2026</a:t>
+              <a:t>17/08/2026</a:t>
             </a:fld>
             <a:endParaRPr lang="en-GB"/>
           </a:p>
@@ -1973,7 +1974,7 @@
           <a:p>
             <a:fld id="{A570D5E4-9820-8A4C-880B-D00DFB29381F}" type="datetimeFigureOut">
               <a:rPr lang="en-GB" smtClean="0"/>
-              <a:t>30/04/2026</a:t>
+              <a:t>17/08/2026</a:t>
             </a:fld>
             <a:endParaRPr lang="en-GB"/>
           </a:p>
@@ -2086,7 +2087,7 @@
           <a:p>
             <a:fld id="{A570D5E4-9820-8A4C-880B-D00DFB29381F}" type="datetimeFigureOut">
               <a:rPr lang="en-GB" smtClean="0"/>
-              <a:t>30/04/2026</a:t>
+              <a:t>17/08/2026</a:t>
             </a:fld>
             <a:endParaRPr lang="en-GB"/>
           </a:p>
@@ -2397,7 +2398,7 @@
           <a:p>
             <a:fld id="{A570D5E4-9820-8A4C-880B-D00DFB29381F}" type="datetimeFigureOut">
               <a:rPr lang="en-GB" smtClean="0"/>
-              <a:t>30/04/2026</a:t>
+              <a:t>17/08/2026</a:t>
             </a:fld>
             <a:endParaRPr lang="en-GB"/>
           </a:p>
@@ -2685,7 +2686,7 @@
           <a:p>
             <a:fld id="{A570D5E4-9820-8A4C-880B-D00DFB29381F}" type="datetimeFigureOut">
               <a:rPr lang="en-GB" smtClean="0"/>
-              <a:t>30/04/2026</a:t>
+              <a:t>17/08/2026</a:t>
             </a:fld>
             <a:endParaRPr lang="en-GB"/>
           </a:p>
@@ -2926,7 +2927,7 @@
           <a:p>
             <a:fld id="{A570D5E4-9820-8A4C-880B-D00DFB29381F}" type="datetimeFigureOut">
               <a:rPr lang="en-GB" smtClean="0"/>
-              <a:t>30/04/2026</a:t>
+              <a:t>17/08/2026</a:t>
             </a:fld>
             <a:endParaRPr lang="en-GB"/>
           </a:p>
@@ -3414,7 +3415,7 @@
         <p:spPr>
           <a:xfrm>
             <a:off x="251460" y="6240780"/>
-            <a:ext cx="11766363" cy="369332"/>
+            <a:ext cx="11492377" cy="369332"/>
           </a:xfrm>
           <a:prstGeom prst="rect">
             <a:avLst/>
@@ -3439,7 +3440,7 @@
             </a:r>
             <a:r>
               <a:rPr lang="en-GB" dirty="0"/>
-              <a:t>) 						30</a:t>
+              <a:t>) 				Last Updated 17</a:t>
             </a:r>
             <a:r>
               <a:rPr lang="en-GB" baseline="30000" dirty="0"/>
@@ -3447,7 +3448,7 @@
             </a:r>
             <a:r>
               <a:rPr lang="en-GB" dirty="0"/>
-              <a:t> April 2026</a:t>
+              <a:t> August 2026</a:t>
             </a:r>
           </a:p>
         </p:txBody>
@@ -3466,6 +3467,195 @@
 </file>
 
 <file path=ppt/slides/slide10.xml><?xml version="1.0" encoding="utf-8"?>
+<p:sld xmlns:a="http://schemas.openxmlformats.org/drawingml/2006/main" xmlns:r="http://schemas.openxmlformats.org/officeDocument/2006/relationships" xmlns:p="http://schemas.openxmlformats.org/presentationml/2006/main">
+  <p:cSld>
+    <p:spTree>
+      <p:nvGrpSpPr>
+        <p:cNvPr id="1" name="">
+          <a:extLst>
+            <a:ext uri="{FF2B5EF4-FFF2-40B4-BE49-F238E27FC236}">
+              <a16:creationId xmlns:a16="http://schemas.microsoft.com/office/drawing/2014/main" id="{732C780D-D719-B51F-8A59-8959F2B27CDA}"/>
+            </a:ext>
+          </a:extLst>
+        </p:cNvPr>
+        <p:cNvGrpSpPr/>
+        <p:nvPr/>
+      </p:nvGrpSpPr>
+      <p:grpSpPr>
+        <a:xfrm>
+          <a:off x="0" y="0"/>
+          <a:ext cx="0" cy="0"/>
+          <a:chOff x="0" y="0"/>
+          <a:chExt cx="0" cy="0"/>
+        </a:xfrm>
+      </p:grpSpPr>
+      <p:pic>
+        <p:nvPicPr>
+          <p:cNvPr id="7" name="Picture 6">
+            <a:extLst>
+              <a:ext uri="{FF2B5EF4-FFF2-40B4-BE49-F238E27FC236}">
+                <a16:creationId xmlns:a16="http://schemas.microsoft.com/office/drawing/2014/main" id="{BC7B4B8B-95A5-87D0-E84B-910687FD28BD}"/>
+              </a:ext>
+            </a:extLst>
+          </p:cNvPr>
+          <p:cNvPicPr>
+            <a:picLocks noChangeAspect="1"/>
+          </p:cNvPicPr>
+          <p:nvPr/>
+        </p:nvPicPr>
+        <p:blipFill>
+          <a:blip r:embed="rId2"/>
+          <a:stretch>
+            <a:fillRect/>
+          </a:stretch>
+        </p:blipFill>
+        <p:spPr>
+          <a:xfrm>
+            <a:off x="838200" y="877618"/>
+            <a:ext cx="9446558" cy="3667487"/>
+          </a:xfrm>
+          <a:prstGeom prst="rect">
+            <a:avLst/>
+          </a:prstGeom>
+        </p:spPr>
+      </p:pic>
+      <p:sp>
+        <p:nvSpPr>
+          <p:cNvPr id="2" name="Title 1">
+            <a:extLst>
+              <a:ext uri="{FF2B5EF4-FFF2-40B4-BE49-F238E27FC236}">
+                <a16:creationId xmlns:a16="http://schemas.microsoft.com/office/drawing/2014/main" id="{716E9064-B4D0-1BE5-1C6C-2ED50D1131EE}"/>
+              </a:ext>
+            </a:extLst>
+          </p:cNvPr>
+          <p:cNvSpPr>
+            <a:spLocks noGrp="1"/>
+          </p:cNvSpPr>
+          <p:nvPr>
+            <p:ph type="title"/>
+          </p:nvPr>
+        </p:nvSpPr>
+        <p:spPr>
+          <a:xfrm>
+            <a:off x="3348318" y="311336"/>
+            <a:ext cx="8234082" cy="1325563"/>
+          </a:xfrm>
+        </p:spPr>
+        <p:txBody>
+          <a:bodyPr/>
+          <a:lstStyle/>
+          <a:p>
+            <a:r>
+              <a:rPr lang="en-GB" dirty="0"/>
+              <a:t>Editing Citation Records (UI)</a:t>
+            </a:r>
+          </a:p>
+        </p:txBody>
+      </p:sp>
+      <p:sp>
+        <p:nvSpPr>
+          <p:cNvPr id="5" name="Content Placeholder 4">
+            <a:extLst>
+              <a:ext uri="{FF2B5EF4-FFF2-40B4-BE49-F238E27FC236}">
+                <a16:creationId xmlns:a16="http://schemas.microsoft.com/office/drawing/2014/main" id="{B6EED2DC-185D-D961-FC70-4B4B38183436}"/>
+              </a:ext>
+            </a:extLst>
+          </p:cNvPr>
+          <p:cNvSpPr>
+            <a:spLocks noGrp="1"/>
+          </p:cNvSpPr>
+          <p:nvPr>
+            <p:ph idx="1"/>
+          </p:nvPr>
+        </p:nvSpPr>
+        <p:spPr>
+          <a:xfrm>
+            <a:off x="838200" y="4545105"/>
+            <a:ext cx="10515600" cy="1631857"/>
+          </a:xfrm>
+        </p:spPr>
+        <p:txBody>
+          <a:bodyPr>
+            <a:normAutofit lnSpcReduction="10000"/>
+          </a:bodyPr>
+          <a:lstStyle/>
+          <a:p>
+            <a:r>
+              <a:rPr lang="en-GB" dirty="0"/>
+              <a:t>Any number of contacts may be added. If they are present in other records their information will be connected inside the service.</a:t>
+            </a:r>
+          </a:p>
+          <a:p>
+            <a:r>
+              <a:rPr lang="en-GB" dirty="0"/>
+              <a:t>One author must be selected as ‘Primary’, all other authors will be listed as Contacts</a:t>
+            </a:r>
+          </a:p>
+        </p:txBody>
+      </p:sp>
+      <p:sp>
+        <p:nvSpPr>
+          <p:cNvPr id="4" name="Rectangle 3">
+            <a:extLst>
+              <a:ext uri="{FF2B5EF4-FFF2-40B4-BE49-F238E27FC236}">
+                <a16:creationId xmlns:a16="http://schemas.microsoft.com/office/drawing/2014/main" id="{8BEBBAB4-555F-6EE7-46F0-8720F3D1EE42}"/>
+              </a:ext>
+            </a:extLst>
+          </p:cNvPr>
+          <p:cNvSpPr/>
+          <p:nvPr/>
+        </p:nvSpPr>
+        <p:spPr>
+          <a:xfrm>
+            <a:off x="8355330" y="2934923"/>
+            <a:ext cx="2663190" cy="1182614"/>
+          </a:xfrm>
+          <a:prstGeom prst="rect">
+            <a:avLst/>
+          </a:prstGeom>
+        </p:spPr>
+        <p:style>
+          <a:lnRef idx="2">
+            <a:schemeClr val="accent6">
+              <a:shade val="15000"/>
+            </a:schemeClr>
+          </a:lnRef>
+          <a:fillRef idx="1">
+            <a:schemeClr val="accent6"/>
+          </a:fillRef>
+          <a:effectRef idx="0">
+            <a:schemeClr val="accent6"/>
+          </a:effectRef>
+          <a:fontRef idx="minor">
+            <a:schemeClr val="lt1"/>
+          </a:fontRef>
+        </p:style>
+        <p:txBody>
+          <a:bodyPr rtlCol="0" anchor="ctr"/>
+          <a:lstStyle/>
+          <a:p>
+            <a:pPr algn="ctr"/>
+            <a:r>
+              <a:rPr lang="en-GB" dirty="0"/>
+              <a:t>Note: Contacts rows are now rearrangeable in the UI by drag-&amp;-drop! (17/08/2026)</a:t>
+            </a:r>
+          </a:p>
+        </p:txBody>
+      </p:sp>
+    </p:spTree>
+    <p:extLst>
+      <p:ext uri="{BB962C8B-B14F-4D97-AF65-F5344CB8AC3E}">
+        <p14:creationId xmlns:p14="http://schemas.microsoft.com/office/powerpoint/2010/main" val="2528125931"/>
+      </p:ext>
+    </p:extLst>
+  </p:cSld>
+  <p:clrMapOvr>
+    <a:masterClrMapping/>
+  </p:clrMapOvr>
+</p:sld>
+</file>
+
+<file path=ppt/slides/slide11.xml><?xml version="1.0" encoding="utf-8"?>
 <p:sld xmlns:a="http://schemas.openxmlformats.org/drawingml/2006/main" xmlns:r="http://schemas.openxmlformats.org/officeDocument/2006/relationships" xmlns:p="http://schemas.openxmlformats.org/presentationml/2006/main">
   <p:cSld>
     <p:spTree>
@@ -3605,7 +3795,7 @@
 </p:sld>
 </file>
 
-<file path=ppt/slides/slide11.xml><?xml version="1.0" encoding="utf-8"?>
+<file path=ppt/slides/slide12.xml><?xml version="1.0" encoding="utf-8"?>
 <p:sld xmlns:a="http://schemas.openxmlformats.org/drawingml/2006/main" xmlns:r="http://schemas.openxmlformats.org/officeDocument/2006/relationships" xmlns:p="http://schemas.openxmlformats.org/presentationml/2006/main">
   <p:cSld>
     <p:spTree>
@@ -3748,7 +3938,7 @@
 </p:sld>
 </file>
 
-<file path=ppt/slides/slide12.xml><?xml version="1.0" encoding="utf-8"?>
+<file path=ppt/slides/slide13.xml><?xml version="1.0" encoding="utf-8"?>
 <p:sld xmlns:a="http://schemas.openxmlformats.org/drawingml/2006/main" xmlns:r="http://schemas.openxmlformats.org/officeDocument/2006/relationships" xmlns:p="http://schemas.openxmlformats.org/presentationml/2006/main">
   <p:cSld>
     <p:spTree>
@@ -3882,7 +4072,7 @@
 </p:sld>
 </file>
 
-<file path=ppt/slides/slide13.xml><?xml version="1.0" encoding="utf-8"?>
+<file path=ppt/slides/slide14.xml><?xml version="1.0" encoding="utf-8"?>
 <p:sld xmlns:a="http://schemas.openxmlformats.org/drawingml/2006/main" xmlns:r="http://schemas.openxmlformats.org/officeDocument/2006/relationships" xmlns:p="http://schemas.openxmlformats.org/presentationml/2006/main">
   <p:cSld>
     <p:spTree>
@@ -4033,7 +4223,7 @@
 </p:sld>
 </file>
 
-<file path=ppt/slides/slide14.xml><?xml version="1.0" encoding="utf-8"?>
+<file path=ppt/slides/slide15.xml><?xml version="1.0" encoding="utf-8"?>
 <p:sld xmlns:a="http://schemas.openxmlformats.org/drawingml/2006/main" xmlns:r="http://schemas.openxmlformats.org/officeDocument/2006/relationships" xmlns:p="http://schemas.openxmlformats.org/presentationml/2006/main">
   <p:cSld>
     <p:spTree>
@@ -4274,7 +4464,7 @@
 </p:sld>
 </file>
 
-<file path=ppt/slides/slide15.xml><?xml version="1.0" encoding="utf-8"?>
+<file path=ppt/slides/slide16.xml><?xml version="1.0" encoding="utf-8"?>
 <p:sld xmlns:a="http://schemas.openxmlformats.org/drawingml/2006/main" xmlns:r="http://schemas.openxmlformats.org/officeDocument/2006/relationships" xmlns:p="http://schemas.openxmlformats.org/presentationml/2006/main">
   <p:cSld>
     <p:spTree>
@@ -4405,7 +4595,7 @@
 </p:sld>
 </file>
 
-<file path=ppt/slides/slide16.xml><?xml version="1.0" encoding="utf-8"?>
+<file path=ppt/slides/slide17.xml><?xml version="1.0" encoding="utf-8"?>
 <p:sld xmlns:a="http://schemas.openxmlformats.org/drawingml/2006/main" xmlns:r="http://schemas.openxmlformats.org/officeDocument/2006/relationships" xmlns:p="http://schemas.openxmlformats.org/presentationml/2006/main">
   <p:cSld>
     <p:spTree>
@@ -4630,7 +4820,7 @@
 </p:sld>
 </file>
 
-<file path=ppt/slides/slide17.xml><?xml version="1.0" encoding="utf-8"?>
+<file path=ppt/slides/slide18.xml><?xml version="1.0" encoding="utf-8"?>
 <p:sld xmlns:a="http://schemas.openxmlformats.org/drawingml/2006/main" xmlns:r="http://schemas.openxmlformats.org/officeDocument/2006/relationships" xmlns:p="http://schemas.openxmlformats.org/presentationml/2006/main">
   <p:cSld>
     <p:spTree>
@@ -4770,7 +4960,7 @@
 </p:sld>
 </file>
 
-<file path=ppt/slides/slide18.xml><?xml version="1.0" encoding="utf-8"?>
+<file path=ppt/slides/slide19.xml><?xml version="1.0" encoding="utf-8"?>
 <p:sld xmlns:a="http://schemas.openxmlformats.org/drawingml/2006/main" xmlns:r="http://schemas.openxmlformats.org/officeDocument/2006/relationships" xmlns:p="http://schemas.openxmlformats.org/presentationml/2006/main">
   <p:cSld>
     <p:spTree>

</xml_diff>